<commit_message>
docs(m1): update course overview material
</commit_message>
<xml_diff>
--- a/docs/M1-Overview.pptx
+++ b/docs/M1-Overview.pptx
@@ -7408,7 +7408,7 @@
           <a:bodyPr/>
           <a:lstStyle/>
           <a:p>
-            <a:endParaRPr lang="en-US"/>
+            <a:endParaRPr lang="en-US" dirty="0"/>
           </a:p>
         </p:txBody>
       </p:sp>
@@ -7692,8 +7692,8 @@
         </p:nvSpPr>
         <p:spPr>
           <a:xfrm>
-            <a:off x="706419" y="3643640"/>
-            <a:ext cx="2834640" cy="1554480"/>
+            <a:off x="706419" y="2992892"/>
+            <a:ext cx="2555181" cy="2205228"/>
           </a:xfrm>
           <a:prstGeom prst="rect">
             <a:avLst/>
@@ -7795,90 +7795,6 @@
               </a:defRPr>
             </a:lvl9pPr>
           </a:lstStyle>
-          <a:p>
-            <a:pPr lvl="0"/>
-            <a:r>
-              <a:rPr lang="en-US" u="sng" dirty="0" err="1">
-                <a:hlinkClick r:id="rId2"/>
-              </a:rPr>
-              <a:t>Demoqa</a:t>
-            </a:r>
-            <a:endParaRPr lang="en-US" u="sng" dirty="0">
-              <a:hlinkClick r:id="rId2"/>
-            </a:endParaRPr>
-          </a:p>
-          <a:p>
-            <a:pPr lvl="0"/>
-            <a:r>
-              <a:rPr lang="en-US" u="sng" dirty="0">
-                <a:hlinkClick r:id="rId2"/>
-              </a:rPr>
-              <a:t>QA Playground</a:t>
-            </a:r>
-            <a:endParaRPr lang="en-US" u="sng" dirty="0"/>
-          </a:p>
-          <a:p>
-            <a:r>
-              <a:rPr lang="en-US" u="sng" dirty="0">
-                <a:hlinkClick r:id="rId3"/>
-              </a:rPr>
-              <a:t>The Internet (</a:t>
-            </a:r>
-            <a:r>
-              <a:rPr lang="en-US" u="sng" dirty="0" err="1">
-                <a:hlinkClick r:id="rId3"/>
-              </a:rPr>
-              <a:t>Herokuapp</a:t>
-            </a:r>
-            <a:r>
-              <a:rPr lang="en-US" u="sng" dirty="0">
-                <a:hlinkClick r:id="rId3"/>
-              </a:rPr>
-              <a:t>)</a:t>
-            </a:r>
-            <a:endParaRPr lang="en-US" u="sng" dirty="0"/>
-          </a:p>
-          <a:p>
-            <a:pPr lvl="0"/>
-            <a:r>
-              <a:rPr lang="en-US" u="sng" dirty="0" err="1">
-                <a:hlinkClick r:id="rId4"/>
-              </a:rPr>
-              <a:t>SauceDemo</a:t>
-            </a:r>
-            <a:r>
-              <a:rPr lang="en-US" dirty="0"/>
-              <a:t> </a:t>
-            </a:r>
-          </a:p>
-          <a:p>
-            <a:pPr lvl="0"/>
-            <a:endParaRPr lang="en-US" dirty="0"/>
-          </a:p>
-          <a:p>
-            <a:r>
-              <a:rPr lang="en-US" u="sng" dirty="0">
-                <a:hlinkClick r:id="rId5"/>
-              </a:rPr>
-              <a:t>Automation Exercise</a:t>
-            </a:r>
-            <a:r>
-              <a:rPr lang="en-US" dirty="0"/>
-              <a:t> </a:t>
-            </a:r>
-          </a:p>
-          <a:p>
-            <a:r>
-              <a:rPr lang="en-US" u="sng" dirty="0">
-                <a:hlinkClick r:id="rId6"/>
-              </a:rPr>
-              <a:t>UI Testing Playground</a:t>
-            </a:r>
-            <a:r>
-              <a:rPr lang="en-US" dirty="0"/>
-              <a:t> </a:t>
-            </a:r>
-          </a:p>
           <a:p>
             <a:pPr lvl="0"/>
             <a:endParaRPr lang="en-US" dirty="0"/>
@@ -8364,7 +8280,7 @@
                 <a:solidFill>
                   <a:srgbClr val="333333"/>
                 </a:solidFill>
-                <a:hlinkClick r:id="rId7"/>
+                <a:hlinkClick r:id="rId2"/>
               </a:rPr>
               <a:t>web-automation Repo</a:t>
             </a:r>
@@ -8660,8 +8576,8 @@
         </p:nvSpPr>
         <p:spPr>
           <a:xfrm>
-            <a:off x="6717323" y="3131945"/>
-            <a:ext cx="2722245" cy="1554480"/>
+            <a:off x="6780880" y="3275480"/>
+            <a:ext cx="1903860" cy="1554480"/>
           </a:xfrm>
           <a:prstGeom prst="rect">
             <a:avLst/>
@@ -8769,11 +8685,180 @@
                 <a:solidFill>
                   <a:srgbClr val="333333"/>
                 </a:solidFill>
+                <a:hlinkClick r:id="rId3"/>
+              </a:rPr>
+              <a:t>Web Automation Classroom</a:t>
+            </a:r>
+            <a:br>
+              <a:rPr lang="en-US" dirty="0">
+                <a:solidFill>
+                  <a:srgbClr val="333333"/>
+                </a:solidFill>
+              </a:rPr>
+            </a:br>
+            <a:br>
+              <a:rPr lang="en-US" dirty="0">
+                <a:solidFill>
+                  <a:srgbClr val="333333"/>
+                </a:solidFill>
+              </a:rPr>
+            </a:br>
+            <a:r>
+              <a:rPr lang="en-US" dirty="0">
+                <a:solidFill>
+                  <a:srgbClr val="333333"/>
+                </a:solidFill>
+                <a:hlinkClick r:id="rId4"/>
+              </a:rPr>
+              <a:t>Invitation Link</a:t>
+            </a:r>
+            <a:br>
+              <a:rPr lang="en-US" dirty="0">
+                <a:solidFill>
+                  <a:srgbClr val="333333"/>
+                </a:solidFill>
+              </a:rPr>
+            </a:br>
+            <a:br>
+              <a:rPr lang="en-US" dirty="0">
+                <a:solidFill>
+                  <a:srgbClr val="333333"/>
+                </a:solidFill>
+              </a:rPr>
+            </a:br>
+            <a:r>
+              <a:rPr lang="en-US" dirty="0">
+                <a:solidFill>
+                  <a:srgbClr val="333333"/>
+                </a:solidFill>
+              </a:rPr>
+              <a:t>Code: krzrsii7</a:t>
+            </a:r>
+            <a:endParaRPr lang="en-US" dirty="0"/>
+          </a:p>
+        </p:txBody>
+      </p:sp>
+      <p:sp>
+        <p:nvSpPr>
+          <p:cNvPr id="6" name="TextBox 5">
+            <a:extLst>
+              <a:ext uri="{FF2B5EF4-FFF2-40B4-BE49-F238E27FC236}">
+                <a16:creationId xmlns:a16="http://schemas.microsoft.com/office/drawing/2014/main" id="{91D1B136-8307-13E4-EF1A-71ACF62490A2}"/>
+              </a:ext>
+            </a:extLst>
+          </p:cNvPr>
+          <p:cNvSpPr txBox="1"/>
+          <p:nvPr/>
+        </p:nvSpPr>
+        <p:spPr>
+          <a:xfrm>
+            <a:off x="706419" y="3076865"/>
+            <a:ext cx="2714020" cy="2031325"/>
+          </a:xfrm>
+          <a:prstGeom prst="rect">
+            <a:avLst/>
+          </a:prstGeom>
+          <a:noFill/>
+        </p:spPr>
+        <p:txBody>
+          <a:bodyPr wrap="square">
+            <a:spAutoFit/>
+          </a:bodyPr>
+          <a:lstStyle/>
+          <a:p>
+            <a:pPr lvl="0"/>
+            <a:r>
+              <a:rPr lang="en-US" sz="1800" u="sng" dirty="0">
+                <a:hlinkClick r:id="rId5"/>
+              </a:rPr>
+              <a:t>QA Playground</a:t>
+            </a:r>
+            <a:endParaRPr lang="en-US" sz="1800" u="sng" dirty="0"/>
+          </a:p>
+          <a:p>
+            <a:r>
+              <a:rPr lang="en-US" sz="1800" u="sng" dirty="0">
+                <a:hlinkClick r:id="rId6"/>
+              </a:rPr>
+              <a:t>The Internet (</a:t>
+            </a:r>
+            <a:r>
+              <a:rPr lang="en-US" sz="1800" u="sng" dirty="0" err="1">
+                <a:hlinkClick r:id="rId6"/>
+              </a:rPr>
+              <a:t>Herokuapp</a:t>
+            </a:r>
+            <a:r>
+              <a:rPr lang="en-US" sz="1800" u="sng" dirty="0">
+                <a:hlinkClick r:id="rId6"/>
+              </a:rPr>
+              <a:t>)</a:t>
+            </a:r>
+            <a:endParaRPr lang="en-US" sz="1800" u="sng" dirty="0"/>
+          </a:p>
+          <a:p>
+            <a:pPr lvl="0"/>
+            <a:r>
+              <a:rPr lang="en-US" sz="1800" u="sng" dirty="0" err="1">
+                <a:hlinkClick r:id="rId7"/>
+              </a:rPr>
+              <a:t>SauceDemo</a:t>
+            </a:r>
+            <a:r>
+              <a:rPr lang="en-US" sz="1800" dirty="0"/>
+              <a:t> </a:t>
+            </a:r>
+          </a:p>
+          <a:p>
+            <a:pPr lvl="0"/>
+            <a:r>
+              <a:rPr lang="en-US" dirty="0">
                 <a:hlinkClick r:id="rId8"/>
               </a:rPr>
-              <a:t>Web Automation Classroom</a:t>
-            </a:r>
-            <a:endParaRPr lang="en-US" dirty="0"/>
+              <a:t>todo.ly</a:t>
+            </a:r>
+            <a:r>
+              <a:rPr lang="en-US" dirty="0"/>
+              <a:t> </a:t>
+            </a:r>
+            <a:endParaRPr lang="en-US" sz="1800" dirty="0"/>
+          </a:p>
+          <a:p>
+            <a:r>
+              <a:rPr lang="en-US" sz="1800" u="sng" dirty="0">
+                <a:hlinkClick r:id="rId9"/>
+              </a:rPr>
+              <a:t>Automation Exercise</a:t>
+            </a:r>
+            <a:r>
+              <a:rPr lang="en-US" sz="1800" dirty="0"/>
+              <a:t> </a:t>
+            </a:r>
+          </a:p>
+          <a:p>
+            <a:r>
+              <a:rPr lang="en-US" sz="1800" u="sng" dirty="0">
+                <a:hlinkClick r:id="rId10"/>
+              </a:rPr>
+              <a:t>UI Testing Playground</a:t>
+            </a:r>
+            <a:r>
+              <a:rPr lang="en-US" sz="1800" dirty="0"/>
+              <a:t> </a:t>
+            </a:r>
+          </a:p>
+          <a:p>
+            <a:r>
+              <a:rPr lang="en-US">
+                <a:hlinkClick r:id="rId11"/>
+              </a:rPr>
+              <a:t>demoqa.com</a:t>
+            </a:r>
+            <a:r>
+              <a:rPr lang="en-US"/>
+              <a:t> </a:t>
+            </a:r>
+            <a:endParaRPr lang="en-US" sz="1800" dirty="0"/>
           </a:p>
         </p:txBody>
       </p:sp>
@@ -9668,6 +9753,42 @@
                 <a:latin typeface="Aptos" pitchFamily="34" charset="0"/>
               </a:rPr>
               <a:t>📋 Select a project user flow.</a:t>
+            </a:r>
+          </a:p>
+          <a:p>
+            <a:pPr fontAlgn="t">
+              <a:lnSpc>
+                <a:spcPct val="150000"/>
+              </a:lnSpc>
+              <a:buSzPct val="100000"/>
+              <a:buNone/>
+            </a:pPr>
+            <a:r>
+              <a:rPr lang="en-US" dirty="0">
+                <a:solidFill>
+                  <a:srgbClr val="26343B"/>
+                </a:solidFill>
+                <a:latin typeface="Aptos" pitchFamily="34" charset="0"/>
+              </a:rPr>
+              <a:t>📋 Clone </a:t>
+            </a:r>
+            <a:r>
+              <a:rPr lang="en-US" dirty="0">
+                <a:solidFill>
+                  <a:srgbClr val="333333"/>
+                </a:solidFill>
+                <a:hlinkClick r:id="rId3"/>
+              </a:rPr>
+              <a:t>web-automation </a:t>
+            </a:r>
+            <a:r>
+              <a:rPr lang="en-US" dirty="0">
+                <a:solidFill>
+                  <a:srgbClr val="26343B"/>
+                </a:solidFill>
+                <a:latin typeface="Aptos" pitchFamily="34" charset="0"/>
+              </a:rPr>
+              <a:t>Repository </a:t>
             </a:r>
           </a:p>
         </p:txBody>

</xml_diff>